<commit_message>
Stack the presenter names in one column.
Nancy Verma and Amisha Singh now sit one under the other on the title slide and the thank-you slide.

Co-authored-by: Nancy20052020 <Nancy20052020@users.noreply.github.com>
</commit_message>
<xml_diff>
--- a/Team65_FinSight_Pitch.pptx
+++ b/Team65_FinSight_Pitch.pptx
@@ -3186,8 +3186,8 @@
         </p:nvSpPr>
         <p:spPr>
           <a:xfrm>
-            <a:off x="777240" y="438912"/>
-            <a:ext cx="10058400" cy="329184"/>
+            <a:off x="777240" y="347472"/>
+            <a:ext cx="10058400" cy="310896"/>
           </a:xfrm>
           <a:prstGeom prst="rect">
             <a:avLst/>
@@ -3228,8 +3228,8 @@
         </p:nvSpPr>
         <p:spPr>
           <a:xfrm>
-            <a:off x="777240" y="1234440"/>
-            <a:ext cx="10515600" cy="1051560"/>
+            <a:off x="777240" y="777240"/>
+            <a:ext cx="10515600" cy="868680"/>
           </a:xfrm>
           <a:prstGeom prst="rect">
             <a:avLst/>
@@ -3249,7 +3249,7 @@
               </a:spcAft>
             </a:pPr>
             <a:r>
-              <a:rPr sz="6600" b="1" i="0">
+              <a:rPr sz="6000" b="1" i="0">
                 <a:solidFill>
                   <a:srgbClr val="FFFFFF"/>
                 </a:solidFill>
@@ -3270,8 +3270,8 @@
         </p:nvSpPr>
         <p:spPr>
           <a:xfrm>
-            <a:off x="777240" y="2331720"/>
-            <a:ext cx="10058400" cy="548640"/>
+            <a:off x="777240" y="1691640"/>
+            <a:ext cx="10058400" cy="457200"/>
           </a:xfrm>
           <a:prstGeom prst="rect">
             <a:avLst/>
@@ -3291,7 +3291,7 @@
               </a:spcAft>
             </a:pPr>
             <a:r>
-              <a:rPr sz="2800" b="0" i="0">
+              <a:rPr sz="2600" b="0" i="0">
                 <a:solidFill>
                   <a:srgbClr val="E7F3EE"/>
                 </a:solidFill>
@@ -3312,7 +3312,7 @@
         </p:nvSpPr>
         <p:spPr>
           <a:xfrm>
-            <a:off x="777240" y="3108960"/>
+            <a:off x="777240" y="2331720"/>
             <a:ext cx="2194560" cy="54864"/>
           </a:xfrm>
           <a:prstGeom prst="rect">
@@ -3353,8 +3353,8 @@
         </p:nvSpPr>
         <p:spPr>
           <a:xfrm>
-            <a:off x="777240" y="3429000"/>
-            <a:ext cx="5120640" cy="548640"/>
+            <a:off x="777240" y="2606040"/>
+            <a:ext cx="9144000" cy="502920"/>
           </a:xfrm>
           <a:prstGeom prst="rect">
             <a:avLst/>
@@ -3374,7 +3374,7 @@
               </a:spcAft>
             </a:pPr>
             <a:r>
-              <a:rPr sz="3200" b="1" i="0">
+              <a:rPr sz="3000" b="1" i="0">
                 <a:solidFill>
                   <a:srgbClr val="FFFFFF"/>
                 </a:solidFill>
@@ -3382,6 +3382,48 @@
                 <a:cs typeface="Calibri"/>
                 <a:ea typeface="Calibri"/>
               </a:rPr>
+              <a:t>Nancy Verma</a:t>
+            </a:r>
+          </a:p>
+        </p:txBody>
+      </p:sp>
+      <p:sp>
+        <p:nvSpPr>
+          <p:cNvPr id="9" name="TextBox 8"/>
+          <p:cNvSpPr txBox="1"/>
+          <p:nvPr/>
+        </p:nvSpPr>
+        <p:spPr>
+          <a:xfrm>
+            <a:off x="777240" y="3154680"/>
+            <a:ext cx="9144000" cy="502920"/>
+          </a:xfrm>
+          <a:prstGeom prst="rect">
+            <a:avLst/>
+          </a:prstGeom>
+          <a:noFill/>
+        </p:spPr>
+        <p:txBody>
+          <a:bodyPr wrap="square" lIns="0" rIns="0" tIns="0" bIns="0" anchor="t"/>
+          <a:lstStyle/>
+          <a:p>
+            <a:pPr algn="l">
+              <a:spcBef>
+                <a:spcPts val="0"/>
+              </a:spcBef>
+              <a:spcAft>
+                <a:spcPts val="0"/>
+              </a:spcAft>
+            </a:pPr>
+            <a:r>
+              <a:rPr sz="3000" b="1" i="0">
+                <a:solidFill>
+                  <a:srgbClr val="FFFFFF"/>
+                </a:solidFill>
+                <a:latin typeface="Calibri"/>
+                <a:cs typeface="Calibri"/>
+                <a:ea typeface="Calibri"/>
+              </a:rPr>
               <a:t>Amisha Singh</a:t>
             </a:r>
           </a:p>
@@ -3389,14 +3431,14 @@
       </p:sp>
       <p:sp>
         <p:nvSpPr>
-          <p:cNvPr id="9" name="TextBox 8"/>
-          <p:cNvSpPr txBox="1"/>
-          <p:nvPr/>
-        </p:nvSpPr>
-        <p:spPr>
-          <a:xfrm>
-            <a:off x="6126480" y="3429000"/>
-            <a:ext cx="5120640" cy="548640"/>
+          <p:cNvPr id="10" name="TextBox 9"/>
+          <p:cNvSpPr txBox="1"/>
+          <p:nvPr/>
+        </p:nvSpPr>
+        <p:spPr>
+          <a:xfrm>
+            <a:off x="777240" y="3840480"/>
+            <a:ext cx="9144000" cy="384048"/>
           </a:xfrm>
           <a:prstGeom prst="rect">
             <a:avLst/>
@@ -3416,7 +3458,49 @@
               </a:spcAft>
             </a:pPr>
             <a:r>
-              <a:rPr sz="3200" b="1" i="0">
+              <a:rPr sz="2200" b="1" i="0">
+                <a:solidFill>
+                  <a:srgbClr val="C4922A"/>
+                </a:solidFill>
+                <a:latin typeface="Calibri"/>
+                <a:cs typeface="Calibri"/>
+                <a:ea typeface="Calibri"/>
+              </a:rPr>
+              <a:t>Manipal University</a:t>
+            </a:r>
+          </a:p>
+        </p:txBody>
+      </p:sp>
+      <p:sp>
+        <p:nvSpPr>
+          <p:cNvPr id="11" name="TextBox 10"/>
+          <p:cNvSpPr txBox="1"/>
+          <p:nvPr/>
+        </p:nvSpPr>
+        <p:spPr>
+          <a:xfrm>
+            <a:off x="777240" y="4297680"/>
+            <a:ext cx="9144000" cy="365760"/>
+          </a:xfrm>
+          <a:prstGeom prst="rect">
+            <a:avLst/>
+          </a:prstGeom>
+          <a:noFill/>
+        </p:spPr>
+        <p:txBody>
+          <a:bodyPr wrap="square" lIns="0" rIns="0" tIns="0" bIns="0" anchor="t"/>
+          <a:lstStyle/>
+          <a:p>
+            <a:pPr algn="l">
+              <a:spcBef>
+                <a:spcPts val="0"/>
+              </a:spcBef>
+              <a:spcAft>
+                <a:spcPts val="0"/>
+              </a:spcAft>
+            </a:pPr>
+            <a:r>
+              <a:rPr sz="2000" b="1" i="0">
                 <a:solidFill>
                   <a:srgbClr val="FFFFFF"/>
                 </a:solidFill>
@@ -3424,21 +3508,21 @@
                 <a:cs typeface="Calibri"/>
                 <a:ea typeface="Calibri"/>
               </a:rPr>
-              <a:t>Nancy Verma</a:t>
-            </a:r>
-          </a:p>
-        </p:txBody>
-      </p:sp>
-      <p:sp>
-        <p:nvSpPr>
-          <p:cNvPr id="10" name="TextBox 9"/>
-          <p:cNvSpPr txBox="1"/>
-          <p:nvPr/>
-        </p:nvSpPr>
-        <p:spPr>
-          <a:xfrm>
-            <a:off x="777240" y="4069080"/>
-            <a:ext cx="10058400" cy="411480"/>
+              <a:t>Team 65</a:t>
+            </a:r>
+          </a:p>
+        </p:txBody>
+      </p:sp>
+      <p:sp>
+        <p:nvSpPr>
+          <p:cNvPr id="12" name="TextBox 11"/>
+          <p:cNvSpPr txBox="1"/>
+          <p:nvPr/>
+        </p:nvSpPr>
+        <p:spPr>
+          <a:xfrm>
+            <a:off x="777240" y="5349240"/>
+            <a:ext cx="7315200" cy="292608"/>
           </a:xfrm>
           <a:prstGeom prst="rect">
             <a:avLst/>
@@ -3458,90 +3542,6 @@
               </a:spcAft>
             </a:pPr>
             <a:r>
-              <a:rPr sz="2200" b="1" i="0">
-                <a:solidFill>
-                  <a:srgbClr val="C4922A"/>
-                </a:solidFill>
-                <a:latin typeface="Calibri"/>
-                <a:cs typeface="Calibri"/>
-                <a:ea typeface="Calibri"/>
-              </a:rPr>
-              <a:t>Manipal University</a:t>
-            </a:r>
-          </a:p>
-        </p:txBody>
-      </p:sp>
-      <p:sp>
-        <p:nvSpPr>
-          <p:cNvPr id="11" name="TextBox 10"/>
-          <p:cNvSpPr txBox="1"/>
-          <p:nvPr/>
-        </p:nvSpPr>
-        <p:spPr>
-          <a:xfrm>
-            <a:off x="777240" y="4617720"/>
-            <a:ext cx="10058400" cy="365760"/>
-          </a:xfrm>
-          <a:prstGeom prst="rect">
-            <a:avLst/>
-          </a:prstGeom>
-          <a:noFill/>
-        </p:spPr>
-        <p:txBody>
-          <a:bodyPr wrap="square" lIns="0" rIns="0" tIns="0" bIns="0" anchor="t"/>
-          <a:lstStyle/>
-          <a:p>
-            <a:pPr algn="l">
-              <a:spcBef>
-                <a:spcPts val="0"/>
-              </a:spcBef>
-              <a:spcAft>
-                <a:spcPts val="0"/>
-              </a:spcAft>
-            </a:pPr>
-            <a:r>
-              <a:rPr sz="2000" b="1" i="0">
-                <a:solidFill>
-                  <a:srgbClr val="FFFFFF"/>
-                </a:solidFill>
-                <a:latin typeface="Calibri"/>
-                <a:cs typeface="Calibri"/>
-                <a:ea typeface="Calibri"/>
-              </a:rPr>
-              <a:t>Team 65</a:t>
-            </a:r>
-          </a:p>
-        </p:txBody>
-      </p:sp>
-      <p:sp>
-        <p:nvSpPr>
-          <p:cNvPr id="12" name="TextBox 11"/>
-          <p:cNvSpPr txBox="1"/>
-          <p:nvPr/>
-        </p:nvSpPr>
-        <p:spPr>
-          <a:xfrm>
-            <a:off x="777240" y="5623560"/>
-            <a:ext cx="2926080" cy="292608"/>
-          </a:xfrm>
-          <a:prstGeom prst="rect">
-            <a:avLst/>
-          </a:prstGeom>
-          <a:noFill/>
-        </p:spPr>
-        <p:txBody>
-          <a:bodyPr wrap="square" lIns="0" rIns="0" tIns="0" bIns="0" anchor="t"/>
-          <a:lstStyle/>
-          <a:p>
-            <a:pPr algn="l">
-              <a:spcBef>
-                <a:spcPts val="0"/>
-              </a:spcBef>
-              <a:spcAft>
-                <a:spcPts val="0"/>
-              </a:spcAft>
-            </a:pPr>
-            <a:r>
               <a:rPr sz="1500" b="0" i="0">
                 <a:solidFill>
                   <a:srgbClr val="C5D0DC"/>
@@ -3563,7 +3563,7 @@
         </p:nvSpPr>
         <p:spPr>
           <a:xfrm>
-            <a:off x="777240" y="5961888"/>
+            <a:off x="777240" y="5715000"/>
             <a:ext cx="7315200" cy="365760"/>
           </a:xfrm>
           <a:prstGeom prst="rect">
@@ -10118,8 +10118,8 @@
         </p:nvSpPr>
         <p:spPr>
           <a:xfrm>
-            <a:off x="777240" y="1234440"/>
-            <a:ext cx="10515600" cy="1005840"/>
+            <a:off x="777240" y="777240"/>
+            <a:ext cx="10515600" cy="914400"/>
           </a:xfrm>
           <a:prstGeom prst="rect">
             <a:avLst/>
@@ -10139,7 +10139,7 @@
               </a:spcAft>
             </a:pPr>
             <a:r>
-              <a:rPr sz="6400" b="1" i="0">
+              <a:rPr sz="6000" b="1" i="0">
                 <a:solidFill>
                   <a:srgbClr val="FFFFFF"/>
                 </a:solidFill>
@@ -10160,8 +10160,8 @@
         </p:nvSpPr>
         <p:spPr>
           <a:xfrm>
-            <a:off x="777240" y="2423160"/>
-            <a:ext cx="10058400" cy="411480"/>
+            <a:off x="777240" y="1874519"/>
+            <a:ext cx="10058400" cy="384048"/>
           </a:xfrm>
           <a:prstGeom prst="rect">
             <a:avLst/>
@@ -10202,8 +10202,8 @@
         </p:nvSpPr>
         <p:spPr>
           <a:xfrm>
-            <a:off x="777240" y="3246120"/>
-            <a:ext cx="5029200" cy="502920"/>
+            <a:off x="777240" y="2606040"/>
+            <a:ext cx="9144000" cy="502920"/>
           </a:xfrm>
           <a:prstGeom prst="rect">
             <a:avLst/>
@@ -10223,7 +10223,7 @@
               </a:spcAft>
             </a:pPr>
             <a:r>
-              <a:rPr sz="2800" b="1" i="0">
+              <a:rPr sz="3000" b="1" i="0">
                 <a:solidFill>
                   <a:srgbClr val="FFFFFF"/>
                 </a:solidFill>
@@ -10231,6 +10231,48 @@
                 <a:cs typeface="Calibri"/>
                 <a:ea typeface="Calibri"/>
               </a:rPr>
+              <a:t>Nancy Verma</a:t>
+            </a:r>
+          </a:p>
+        </p:txBody>
+      </p:sp>
+      <p:sp>
+        <p:nvSpPr>
+          <p:cNvPr id="7" name="TextBox 6"/>
+          <p:cNvSpPr txBox="1"/>
+          <p:nvPr/>
+        </p:nvSpPr>
+        <p:spPr>
+          <a:xfrm>
+            <a:off x="777240" y="3154680"/>
+            <a:ext cx="9144000" cy="502920"/>
+          </a:xfrm>
+          <a:prstGeom prst="rect">
+            <a:avLst/>
+          </a:prstGeom>
+          <a:noFill/>
+        </p:spPr>
+        <p:txBody>
+          <a:bodyPr wrap="square" lIns="0" rIns="0" tIns="0" bIns="0" anchor="t"/>
+          <a:lstStyle/>
+          <a:p>
+            <a:pPr algn="l">
+              <a:spcBef>
+                <a:spcPts val="0"/>
+              </a:spcBef>
+              <a:spcAft>
+                <a:spcPts val="0"/>
+              </a:spcAft>
+            </a:pPr>
+            <a:r>
+              <a:rPr sz="3000" b="1" i="0">
+                <a:solidFill>
+                  <a:srgbClr val="FFFFFF"/>
+                </a:solidFill>
+                <a:latin typeface="Calibri"/>
+                <a:cs typeface="Calibri"/>
+                <a:ea typeface="Calibri"/>
+              </a:rPr>
               <a:t>Amisha Singh</a:t>
             </a:r>
           </a:p>
@@ -10238,55 +10280,13 @@
       </p:sp>
       <p:sp>
         <p:nvSpPr>
-          <p:cNvPr id="7" name="TextBox 6"/>
-          <p:cNvSpPr txBox="1"/>
-          <p:nvPr/>
-        </p:nvSpPr>
-        <p:spPr>
-          <a:xfrm>
-            <a:off x="6035040" y="3246120"/>
-            <a:ext cx="5029200" cy="502920"/>
-          </a:xfrm>
-          <a:prstGeom prst="rect">
-            <a:avLst/>
-          </a:prstGeom>
-          <a:noFill/>
-        </p:spPr>
-        <p:txBody>
-          <a:bodyPr wrap="square" lIns="0" rIns="0" tIns="0" bIns="0" anchor="t"/>
-          <a:lstStyle/>
-          <a:p>
-            <a:pPr algn="l">
-              <a:spcBef>
-                <a:spcPts val="0"/>
-              </a:spcBef>
-              <a:spcAft>
-                <a:spcPts val="0"/>
-              </a:spcAft>
-            </a:pPr>
-            <a:r>
-              <a:rPr sz="2800" b="1" i="0">
-                <a:solidFill>
-                  <a:srgbClr val="FFFFFF"/>
-                </a:solidFill>
-                <a:latin typeface="Calibri"/>
-                <a:cs typeface="Calibri"/>
-                <a:ea typeface="Calibri"/>
-              </a:rPr>
-              <a:t>Nancy Verma</a:t>
-            </a:r>
-          </a:p>
-        </p:txBody>
-      </p:sp>
-      <p:sp>
-        <p:nvSpPr>
           <p:cNvPr id="8" name="TextBox 7"/>
           <p:cNvSpPr txBox="1"/>
           <p:nvPr/>
         </p:nvSpPr>
         <p:spPr>
           <a:xfrm>
-            <a:off x="777240" y="4434840"/>
+            <a:off x="777240" y="4160520"/>
             <a:ext cx="10058400" cy="365760"/>
           </a:xfrm>
           <a:prstGeom prst="rect">
@@ -10341,7 +10341,7 @@
         </p:nvSpPr>
         <p:spPr>
           <a:xfrm>
-            <a:off x="777240" y="4892040"/>
+            <a:off x="777240" y="4663440"/>
             <a:ext cx="10058400" cy="365760"/>
           </a:xfrm>
           <a:prstGeom prst="rect">

</xml_diff>

<commit_message>
Put Nancy Verma and Amisha Singh in one left column.
The title slide and the thank-you slide now keep both names in a single column. The report presentation link downloads this deck.

Co-authored-by: Nancy20052020 <Nancy20052020@users.noreply.github.com>
</commit_message>
<xml_diff>
--- a/Team65_FinSight_Pitch.pptx
+++ b/Team65_FinSight_Pitch.pptx
@@ -3146,7 +3146,48 @@
         <p:spPr>
           <a:xfrm>
             <a:off x="0" y="0"/>
-            <a:ext cx="164592" cy="6858000"/>
+            <a:ext cx="4709160" cy="6858000"/>
+          </a:xfrm>
+          <a:prstGeom prst="rect">
+            <a:avLst/>
+          </a:prstGeom>
+          <a:solidFill>
+            <a:srgbClr val="081428"/>
+          </a:solidFill>
+          <a:ln>
+            <a:noFill/>
+          </a:ln>
+        </p:spPr>
+        <p:style>
+          <a:lnRef idx="1">
+            <a:schemeClr val="accent1"/>
+          </a:lnRef>
+          <a:fillRef idx="3">
+            <a:schemeClr val="accent1"/>
+          </a:fillRef>
+          <a:effectRef idx="2">
+            <a:schemeClr val="accent1"/>
+          </a:effectRef>
+          <a:fontRef idx="minor">
+            <a:schemeClr val="lt1"/>
+          </a:fontRef>
+        </p:style>
+        <p:txBody>
+          <a:bodyPr rtlCol="0" anchor="ctr"/>
+          <a:lstStyle/>
+          <a:p/>
+        </p:txBody>
+      </p:sp>
+      <p:sp>
+        <p:nvSpPr>
+          <p:cNvPr id="4" name="Rectangle 3"/>
+          <p:cNvSpPr/>
+          <p:nvPr/>
+        </p:nvSpPr>
+        <p:spPr>
+          <a:xfrm>
+            <a:off x="4709160" y="0"/>
+            <a:ext cx="73152" cy="6858000"/>
           </a:xfrm>
           <a:prstGeom prst="rect">
             <a:avLst/>
@@ -3180,14 +3221,14 @@
       </p:sp>
       <p:sp>
         <p:nvSpPr>
-          <p:cNvPr id="4" name="TextBox 3"/>
-          <p:cNvSpPr txBox="1"/>
-          <p:nvPr/>
-        </p:nvSpPr>
-        <p:spPr>
-          <a:xfrm>
-            <a:off x="777240" y="347472"/>
-            <a:ext cx="10058400" cy="310896"/>
+          <p:cNvPr id="5" name="TextBox 4"/>
+          <p:cNvSpPr txBox="1"/>
+          <p:nvPr/>
+        </p:nvSpPr>
+        <p:spPr>
+          <a:xfrm>
+            <a:off x="411480" y="1234440"/>
+            <a:ext cx="4023360" cy="640080"/>
           </a:xfrm>
           <a:prstGeom prst="rect">
             <a:avLst/>
@@ -3207,29 +3248,29 @@
               </a:spcAft>
             </a:pPr>
             <a:r>
-              <a:rPr sz="1600" b="1" i="0">
-                <a:solidFill>
-                  <a:srgbClr val="C4922A"/>
-                </a:solidFill>
-                <a:latin typeface="Calibri"/>
-                <a:cs typeface="Calibri"/>
-                <a:ea typeface="Calibri"/>
-              </a:rPr>
-              <a:t>TRACK 3   ·   FINTECH AI   ·   HACKATHON 4.0</a:t>
-            </a:r>
-          </a:p>
-        </p:txBody>
-      </p:sp>
-      <p:sp>
-        <p:nvSpPr>
-          <p:cNvPr id="5" name="TextBox 4"/>
-          <p:cNvSpPr txBox="1"/>
-          <p:nvPr/>
-        </p:nvSpPr>
-        <p:spPr>
-          <a:xfrm>
-            <a:off x="777240" y="777240"/>
-            <a:ext cx="10515600" cy="868680"/>
+              <a:rPr sz="2800" b="1" i="0">
+                <a:solidFill>
+                  <a:srgbClr val="FFFFFF"/>
+                </a:solidFill>
+                <a:latin typeface="Calibri"/>
+                <a:cs typeface="Calibri"/>
+                <a:ea typeface="Calibri"/>
+              </a:rPr>
+              <a:t>Nancy Verma</a:t>
+            </a:r>
+          </a:p>
+        </p:txBody>
+      </p:sp>
+      <p:sp>
+        <p:nvSpPr>
+          <p:cNvPr id="6" name="TextBox 5"/>
+          <p:cNvSpPr txBox="1"/>
+          <p:nvPr/>
+        </p:nvSpPr>
+        <p:spPr>
+          <a:xfrm>
+            <a:off x="411480" y="1965960"/>
+            <a:ext cx="4023360" cy="640080"/>
           </a:xfrm>
           <a:prstGeom prst="rect">
             <a:avLst/>
@@ -3249,7 +3290,7 @@
               </a:spcAft>
             </a:pPr>
             <a:r>
-              <a:rPr sz="6000" b="1" i="0">
+              <a:rPr sz="2800" b="1" i="0">
                 <a:solidFill>
                   <a:srgbClr val="FFFFFF"/>
                 </a:solidFill>
@@ -3257,49 +3298,7 @@
                 <a:cs typeface="Calibri"/>
                 <a:ea typeface="Calibri"/>
               </a:rPr>
-              <a:t>FinSight AI</a:t>
-            </a:r>
-          </a:p>
-        </p:txBody>
-      </p:sp>
-      <p:sp>
-        <p:nvSpPr>
-          <p:cNvPr id="6" name="TextBox 5"/>
-          <p:cNvSpPr txBox="1"/>
-          <p:nvPr/>
-        </p:nvSpPr>
-        <p:spPr>
-          <a:xfrm>
-            <a:off x="777240" y="1691640"/>
-            <a:ext cx="10058400" cy="457200"/>
-          </a:xfrm>
-          <a:prstGeom prst="rect">
-            <a:avLst/>
-          </a:prstGeom>
-          <a:noFill/>
-        </p:spPr>
-        <p:txBody>
-          <a:bodyPr wrap="square" lIns="0" rIns="0" tIns="0" bIns="0" anchor="t"/>
-          <a:lstStyle/>
-          <a:p>
-            <a:pPr algn="l">
-              <a:spcBef>
-                <a:spcPts val="0"/>
-              </a:spcBef>
-              <a:spcAft>
-                <a:spcPts val="0"/>
-              </a:spcAft>
-            </a:pPr>
-            <a:r>
-              <a:rPr sz="2600" b="0" i="0">
-                <a:solidFill>
-                  <a:srgbClr val="E7F3EE"/>
-                </a:solidFill>
-                <a:latin typeface="Calibri"/>
-                <a:cs typeface="Calibri"/>
-                <a:ea typeface="Calibri"/>
-              </a:rPr>
-              <a:t>Will you run out of cash before payday?</a:t>
+              <a:t>Amisha Singh</a:t>
             </a:r>
           </a:p>
         </p:txBody>
@@ -3312,8 +3311,8 @@
         </p:nvSpPr>
         <p:spPr>
           <a:xfrm>
-            <a:off x="777240" y="2331720"/>
-            <a:ext cx="2194560" cy="54864"/>
+            <a:off x="411480" y="2788920"/>
+            <a:ext cx="1463040" cy="54864"/>
           </a:xfrm>
           <a:prstGeom prst="rect">
             <a:avLst/>
@@ -3353,8 +3352,8 @@
         </p:nvSpPr>
         <p:spPr>
           <a:xfrm>
-            <a:off x="777240" y="2606040"/>
-            <a:ext cx="9144000" cy="502920"/>
+            <a:off x="411480" y="3017520"/>
+            <a:ext cx="4023360" cy="411480"/>
           </a:xfrm>
           <a:prstGeom prst="rect">
             <a:avLst/>
@@ -3374,7 +3373,49 @@
               </a:spcAft>
             </a:pPr>
             <a:r>
-              <a:rPr sz="3000" b="1" i="0">
+              <a:rPr sz="1800" b="1" i="0">
+                <a:solidFill>
+                  <a:srgbClr val="C4922A"/>
+                </a:solidFill>
+                <a:latin typeface="Calibri"/>
+                <a:cs typeface="Calibri"/>
+                <a:ea typeface="Calibri"/>
+              </a:rPr>
+              <a:t>Manipal University</a:t>
+            </a:r>
+          </a:p>
+        </p:txBody>
+      </p:sp>
+      <p:sp>
+        <p:nvSpPr>
+          <p:cNvPr id="9" name="TextBox 8"/>
+          <p:cNvSpPr txBox="1"/>
+          <p:nvPr/>
+        </p:nvSpPr>
+        <p:spPr>
+          <a:xfrm>
+            <a:off x="411480" y="3520440"/>
+            <a:ext cx="4023360" cy="365760"/>
+          </a:xfrm>
+          <a:prstGeom prst="rect">
+            <a:avLst/>
+          </a:prstGeom>
+          <a:noFill/>
+        </p:spPr>
+        <p:txBody>
+          <a:bodyPr wrap="square" lIns="0" rIns="0" tIns="0" bIns="0" anchor="t"/>
+          <a:lstStyle/>
+          <a:p>
+            <a:pPr algn="l">
+              <a:spcBef>
+                <a:spcPts val="0"/>
+              </a:spcBef>
+              <a:spcAft>
+                <a:spcPts val="0"/>
+              </a:spcAft>
+            </a:pPr>
+            <a:r>
+              <a:rPr sz="1800" b="1" i="0">
                 <a:solidFill>
                   <a:srgbClr val="FFFFFF"/>
                 </a:solidFill>
@@ -3382,21 +3423,21 @@
                 <a:cs typeface="Calibri"/>
                 <a:ea typeface="Calibri"/>
               </a:rPr>
-              <a:t>Nancy Verma</a:t>
-            </a:r>
-          </a:p>
-        </p:txBody>
-      </p:sp>
-      <p:sp>
-        <p:nvSpPr>
-          <p:cNvPr id="9" name="TextBox 8"/>
-          <p:cNvSpPr txBox="1"/>
-          <p:nvPr/>
-        </p:nvSpPr>
-        <p:spPr>
-          <a:xfrm>
-            <a:off x="777240" y="3154680"/>
-            <a:ext cx="9144000" cy="502920"/>
+              <a:t>Team 65</a:t>
+            </a:r>
+          </a:p>
+        </p:txBody>
+      </p:sp>
+      <p:sp>
+        <p:nvSpPr>
+          <p:cNvPr id="10" name="TextBox 9"/>
+          <p:cNvSpPr txBox="1"/>
+          <p:nvPr/>
+        </p:nvSpPr>
+        <p:spPr>
+          <a:xfrm>
+            <a:off x="411480" y="3931920"/>
+            <a:ext cx="4023360" cy="365760"/>
           </a:xfrm>
           <a:prstGeom prst="rect">
             <a:avLst/>
@@ -3416,7 +3457,91 @@
               </a:spcAft>
             </a:pPr>
             <a:r>
-              <a:rPr sz="3000" b="1" i="0">
+              <a:rPr sz="1600" b="0" i="0">
+                <a:solidFill>
+                  <a:srgbClr val="C5D0DC"/>
+                </a:solidFill>
+                <a:latin typeface="Calibri"/>
+                <a:cs typeface="Calibri"/>
+                <a:ea typeface="Calibri"/>
+              </a:rPr>
+              <a:t>Hackathon 4.0</a:t>
+            </a:r>
+          </a:p>
+        </p:txBody>
+      </p:sp>
+      <p:sp>
+        <p:nvSpPr>
+          <p:cNvPr id="11" name="TextBox 10"/>
+          <p:cNvSpPr txBox="1"/>
+          <p:nvPr/>
+        </p:nvSpPr>
+        <p:spPr>
+          <a:xfrm>
+            <a:off x="5120640" y="1417320"/>
+            <a:ext cx="6583680" cy="329184"/>
+          </a:xfrm>
+          <a:prstGeom prst="rect">
+            <a:avLst/>
+          </a:prstGeom>
+          <a:noFill/>
+        </p:spPr>
+        <p:txBody>
+          <a:bodyPr wrap="square" lIns="0" rIns="0" tIns="0" bIns="0" anchor="t"/>
+          <a:lstStyle/>
+          <a:p>
+            <a:pPr algn="l">
+              <a:spcBef>
+                <a:spcPts val="0"/>
+              </a:spcBef>
+              <a:spcAft>
+                <a:spcPts val="0"/>
+              </a:spcAft>
+            </a:pPr>
+            <a:r>
+              <a:rPr sz="1600" b="1" i="0">
+                <a:solidFill>
+                  <a:srgbClr val="C4922A"/>
+                </a:solidFill>
+                <a:latin typeface="Calibri"/>
+                <a:cs typeface="Calibri"/>
+                <a:ea typeface="Calibri"/>
+              </a:rPr>
+              <a:t>TRACK 3   ·   FINTECH AI</a:t>
+            </a:r>
+          </a:p>
+        </p:txBody>
+      </p:sp>
+      <p:sp>
+        <p:nvSpPr>
+          <p:cNvPr id="12" name="TextBox 11"/>
+          <p:cNvSpPr txBox="1"/>
+          <p:nvPr/>
+        </p:nvSpPr>
+        <p:spPr>
+          <a:xfrm>
+            <a:off x="5120640" y="1965960"/>
+            <a:ext cx="6583680" cy="1051560"/>
+          </a:xfrm>
+          <a:prstGeom prst="rect">
+            <a:avLst/>
+          </a:prstGeom>
+          <a:noFill/>
+        </p:spPr>
+        <p:txBody>
+          <a:bodyPr wrap="square" lIns="0" rIns="0" tIns="0" bIns="0" anchor="t"/>
+          <a:lstStyle/>
+          <a:p>
+            <a:pPr algn="l">
+              <a:spcBef>
+                <a:spcPts val="0"/>
+              </a:spcBef>
+              <a:spcAft>
+                <a:spcPts val="0"/>
+              </a:spcAft>
+            </a:pPr>
+            <a:r>
+              <a:rPr sz="4800" b="1" i="0">
                 <a:solidFill>
                   <a:srgbClr val="FFFFFF"/>
                 </a:solidFill>
@@ -3424,21 +3549,21 @@
                 <a:cs typeface="Calibri"/>
                 <a:ea typeface="Calibri"/>
               </a:rPr>
-              <a:t>Amisha Singh</a:t>
-            </a:r>
-          </a:p>
-        </p:txBody>
-      </p:sp>
-      <p:sp>
-        <p:nvSpPr>
-          <p:cNvPr id="10" name="TextBox 9"/>
-          <p:cNvSpPr txBox="1"/>
-          <p:nvPr/>
-        </p:nvSpPr>
-        <p:spPr>
-          <a:xfrm>
-            <a:off x="777240" y="3840480"/>
-            <a:ext cx="9144000" cy="384048"/>
+              <a:t>FinSight AI</a:t>
+            </a:r>
+          </a:p>
+        </p:txBody>
+      </p:sp>
+      <p:sp>
+        <p:nvSpPr>
+          <p:cNvPr id="13" name="TextBox 12"/>
+          <p:cNvSpPr txBox="1"/>
+          <p:nvPr/>
+        </p:nvSpPr>
+        <p:spPr>
+          <a:xfrm>
+            <a:off x="5120640" y="3154680"/>
+            <a:ext cx="6583680" cy="1005840"/>
           </a:xfrm>
           <a:prstGeom prst="rect">
             <a:avLst/>
@@ -3458,29 +3583,29 @@
               </a:spcAft>
             </a:pPr>
             <a:r>
-              <a:rPr sz="2200" b="1" i="0">
-                <a:solidFill>
-                  <a:srgbClr val="C4922A"/>
-                </a:solidFill>
-                <a:latin typeface="Calibri"/>
-                <a:cs typeface="Calibri"/>
-                <a:ea typeface="Calibri"/>
-              </a:rPr>
-              <a:t>Manipal University</a:t>
-            </a:r>
-          </a:p>
-        </p:txBody>
-      </p:sp>
-      <p:sp>
-        <p:nvSpPr>
-          <p:cNvPr id="11" name="TextBox 10"/>
-          <p:cNvSpPr txBox="1"/>
-          <p:nvPr/>
-        </p:nvSpPr>
-        <p:spPr>
-          <a:xfrm>
-            <a:off x="777240" y="4297680"/>
-            <a:ext cx="9144000" cy="365760"/>
+              <a:rPr sz="2600" b="0" i="0">
+                <a:solidFill>
+                  <a:srgbClr val="E7F3EE"/>
+                </a:solidFill>
+                <a:latin typeface="Calibri"/>
+                <a:cs typeface="Calibri"/>
+                <a:ea typeface="Calibri"/>
+              </a:rPr>
+              <a:t>Will you run out of cash before payday?</a:t>
+            </a:r>
+          </a:p>
+        </p:txBody>
+      </p:sp>
+      <p:sp>
+        <p:nvSpPr>
+          <p:cNvPr id="14" name="TextBox 13"/>
+          <p:cNvSpPr txBox="1"/>
+          <p:nvPr/>
+        </p:nvSpPr>
+        <p:spPr>
+          <a:xfrm>
+            <a:off x="5120640" y="4892040"/>
+            <a:ext cx="6583680" cy="292608"/>
           </a:xfrm>
           <a:prstGeom prst="rect">
             <a:avLst/>
@@ -3500,29 +3625,29 @@
               </a:spcAft>
             </a:pPr>
             <a:r>
-              <a:rPr sz="2000" b="1" i="0">
-                <a:solidFill>
-                  <a:srgbClr val="FFFFFF"/>
-                </a:solidFill>
-                <a:latin typeface="Calibri"/>
-                <a:cs typeface="Calibri"/>
-                <a:ea typeface="Calibri"/>
-              </a:rPr>
-              <a:t>Team 65</a:t>
-            </a:r>
-          </a:p>
-        </p:txBody>
-      </p:sp>
-      <p:sp>
-        <p:nvSpPr>
-          <p:cNvPr id="12" name="TextBox 11"/>
-          <p:cNvSpPr txBox="1"/>
-          <p:nvPr/>
-        </p:nvSpPr>
-        <p:spPr>
-          <a:xfrm>
-            <a:off x="777240" y="5349240"/>
-            <a:ext cx="7315200" cy="292608"/>
+              <a:rPr sz="1600" b="0" i="0">
+                <a:solidFill>
+                  <a:srgbClr val="C5D0DC"/>
+                </a:solidFill>
+                <a:latin typeface="Calibri"/>
+                <a:cs typeface="Calibri"/>
+                <a:ea typeface="Calibri"/>
+              </a:rPr>
+              <a:t>Live site</a:t>
+            </a:r>
+          </a:p>
+        </p:txBody>
+      </p:sp>
+      <p:sp>
+        <p:nvSpPr>
+          <p:cNvPr id="15" name="TextBox 14"/>
+          <p:cNvSpPr txBox="1"/>
+          <p:nvPr/>
+        </p:nvSpPr>
+        <p:spPr>
+          <a:xfrm>
+            <a:off x="5120640" y="5230368"/>
+            <a:ext cx="6583680" cy="365760"/>
           </a:xfrm>
           <a:prstGeom prst="rect">
             <a:avLst/>
@@ -3541,59 +3666,6 @@
                 <a:spcPts val="0"/>
               </a:spcAft>
             </a:pPr>
-            <a:r>
-              <a:rPr sz="1500" b="0" i="0">
-                <a:solidFill>
-                  <a:srgbClr val="C5D0DC"/>
-                </a:solidFill>
-                <a:latin typeface="Calibri"/>
-                <a:cs typeface="Calibri"/>
-                <a:ea typeface="Calibri"/>
-              </a:rPr>
-              <a:t>Report figures are Harbor &amp; Co.</a:t>
-            </a:r>
-          </a:p>
-        </p:txBody>
-      </p:sp>
-      <p:sp>
-        <p:nvSpPr>
-          <p:cNvPr id="13" name="TextBox 12"/>
-          <p:cNvSpPr txBox="1"/>
-          <p:nvPr/>
-        </p:nvSpPr>
-        <p:spPr>
-          <a:xfrm>
-            <a:off x="777240" y="5715000"/>
-            <a:ext cx="7315200" cy="365760"/>
-          </a:xfrm>
-          <a:prstGeom prst="rect">
-            <a:avLst/>
-          </a:prstGeom>
-          <a:noFill/>
-        </p:spPr>
-        <p:txBody>
-          <a:bodyPr wrap="square" lIns="0" rIns="0" tIns="0" bIns="0" anchor="t"/>
-          <a:lstStyle/>
-          <a:p>
-            <a:pPr algn="l">
-              <a:spcBef>
-                <a:spcPts val="0"/>
-              </a:spcBef>
-              <a:spcAft>
-                <a:spcPts val="0"/>
-              </a:spcAft>
-            </a:pPr>
-            <a:r>
-              <a:rPr sz="1800" b="0" i="0">
-                <a:solidFill>
-                  <a:srgbClr val="C5D0DC"/>
-                </a:solidFill>
-                <a:latin typeface="Calibri"/>
-                <a:cs typeface="Calibri"/>
-                <a:ea typeface="Calibri"/>
-              </a:rPr>
-              <a:t>Live site    </a:t>
-            </a:r>
             <a:r>
               <a:rPr sz="1800" b="1" i="0">
                 <a:solidFill>
@@ -10078,7 +10150,48 @@
         <p:spPr>
           <a:xfrm>
             <a:off x="0" y="0"/>
-            <a:ext cx="164592" cy="6858000"/>
+            <a:ext cx="4709160" cy="6858000"/>
+          </a:xfrm>
+          <a:prstGeom prst="rect">
+            <a:avLst/>
+          </a:prstGeom>
+          <a:solidFill>
+            <a:srgbClr val="081428"/>
+          </a:solidFill>
+          <a:ln>
+            <a:noFill/>
+          </a:ln>
+        </p:spPr>
+        <p:style>
+          <a:lnRef idx="1">
+            <a:schemeClr val="accent1"/>
+          </a:lnRef>
+          <a:fillRef idx="3">
+            <a:schemeClr val="accent1"/>
+          </a:fillRef>
+          <a:effectRef idx="2">
+            <a:schemeClr val="accent1"/>
+          </a:effectRef>
+          <a:fontRef idx="minor">
+            <a:schemeClr val="lt1"/>
+          </a:fontRef>
+        </p:style>
+        <p:txBody>
+          <a:bodyPr rtlCol="0" anchor="ctr"/>
+          <a:lstStyle/>
+          <a:p/>
+        </p:txBody>
+      </p:sp>
+      <p:sp>
+        <p:nvSpPr>
+          <p:cNvPr id="4" name="Rectangle 3"/>
+          <p:cNvSpPr/>
+          <p:nvPr/>
+        </p:nvSpPr>
+        <p:spPr>
+          <a:xfrm>
+            <a:off x="4709160" y="0"/>
+            <a:ext cx="73152" cy="6858000"/>
           </a:xfrm>
           <a:prstGeom prst="rect">
             <a:avLst/>
@@ -10112,14 +10225,14 @@
       </p:sp>
       <p:sp>
         <p:nvSpPr>
-          <p:cNvPr id="4" name="TextBox 3"/>
-          <p:cNvSpPr txBox="1"/>
-          <p:nvPr/>
-        </p:nvSpPr>
-        <p:spPr>
-          <a:xfrm>
-            <a:off x="777240" y="777240"/>
-            <a:ext cx="10515600" cy="914400"/>
+          <p:cNvPr id="5" name="TextBox 4"/>
+          <p:cNvSpPr txBox="1"/>
+          <p:nvPr/>
+        </p:nvSpPr>
+        <p:spPr>
+          <a:xfrm>
+            <a:off x="411480" y="1554480"/>
+            <a:ext cx="4023360" cy="640080"/>
           </a:xfrm>
           <a:prstGeom prst="rect">
             <a:avLst/>
@@ -10139,7 +10252,7 @@
               </a:spcAft>
             </a:pPr>
             <a:r>
-              <a:rPr sz="6000" b="1" i="0">
+              <a:rPr sz="2800" b="1" i="0">
                 <a:solidFill>
                   <a:srgbClr val="FFFFFF"/>
                 </a:solidFill>
@@ -10147,6 +10260,257 @@
                 <a:cs typeface="Calibri"/>
                 <a:ea typeface="Calibri"/>
               </a:rPr>
+              <a:t>Nancy Verma</a:t>
+            </a:r>
+          </a:p>
+        </p:txBody>
+      </p:sp>
+      <p:sp>
+        <p:nvSpPr>
+          <p:cNvPr id="6" name="TextBox 5"/>
+          <p:cNvSpPr txBox="1"/>
+          <p:nvPr/>
+        </p:nvSpPr>
+        <p:spPr>
+          <a:xfrm>
+            <a:off x="411480" y="2286000"/>
+            <a:ext cx="4023360" cy="640080"/>
+          </a:xfrm>
+          <a:prstGeom prst="rect">
+            <a:avLst/>
+          </a:prstGeom>
+          <a:noFill/>
+        </p:spPr>
+        <p:txBody>
+          <a:bodyPr wrap="square" lIns="0" rIns="0" tIns="0" bIns="0" anchor="t"/>
+          <a:lstStyle/>
+          <a:p>
+            <a:pPr algn="l">
+              <a:spcBef>
+                <a:spcPts val="0"/>
+              </a:spcBef>
+              <a:spcAft>
+                <a:spcPts val="0"/>
+              </a:spcAft>
+            </a:pPr>
+            <a:r>
+              <a:rPr sz="2800" b="1" i="0">
+                <a:solidFill>
+                  <a:srgbClr val="FFFFFF"/>
+                </a:solidFill>
+                <a:latin typeface="Calibri"/>
+                <a:cs typeface="Calibri"/>
+                <a:ea typeface="Calibri"/>
+              </a:rPr>
+              <a:t>Amisha Singh</a:t>
+            </a:r>
+          </a:p>
+        </p:txBody>
+      </p:sp>
+      <p:sp>
+        <p:nvSpPr>
+          <p:cNvPr id="7" name="Rectangle 6"/>
+          <p:cNvSpPr/>
+          <p:nvPr/>
+        </p:nvSpPr>
+        <p:spPr>
+          <a:xfrm>
+            <a:off x="411480" y="3108960"/>
+            <a:ext cx="1463040" cy="54864"/>
+          </a:xfrm>
+          <a:prstGeom prst="rect">
+            <a:avLst/>
+          </a:prstGeom>
+          <a:solidFill>
+            <a:srgbClr val="C4922A"/>
+          </a:solidFill>
+          <a:ln>
+            <a:noFill/>
+          </a:ln>
+        </p:spPr>
+        <p:style>
+          <a:lnRef idx="1">
+            <a:schemeClr val="accent1"/>
+          </a:lnRef>
+          <a:fillRef idx="3">
+            <a:schemeClr val="accent1"/>
+          </a:fillRef>
+          <a:effectRef idx="2">
+            <a:schemeClr val="accent1"/>
+          </a:effectRef>
+          <a:fontRef idx="minor">
+            <a:schemeClr val="lt1"/>
+          </a:fontRef>
+        </p:style>
+        <p:txBody>
+          <a:bodyPr rtlCol="0" anchor="ctr"/>
+          <a:lstStyle/>
+          <a:p/>
+        </p:txBody>
+      </p:sp>
+      <p:sp>
+        <p:nvSpPr>
+          <p:cNvPr id="8" name="TextBox 7"/>
+          <p:cNvSpPr txBox="1"/>
+          <p:nvPr/>
+        </p:nvSpPr>
+        <p:spPr>
+          <a:xfrm>
+            <a:off x="411480" y="3337560"/>
+            <a:ext cx="4023360" cy="411480"/>
+          </a:xfrm>
+          <a:prstGeom prst="rect">
+            <a:avLst/>
+          </a:prstGeom>
+          <a:noFill/>
+        </p:spPr>
+        <p:txBody>
+          <a:bodyPr wrap="square" lIns="0" rIns="0" tIns="0" bIns="0" anchor="t"/>
+          <a:lstStyle/>
+          <a:p>
+            <a:pPr algn="l">
+              <a:spcBef>
+                <a:spcPts val="0"/>
+              </a:spcBef>
+              <a:spcAft>
+                <a:spcPts val="0"/>
+              </a:spcAft>
+            </a:pPr>
+            <a:r>
+              <a:rPr sz="1800" b="1" i="0">
+                <a:solidFill>
+                  <a:srgbClr val="C4922A"/>
+                </a:solidFill>
+                <a:latin typeface="Calibri"/>
+                <a:cs typeface="Calibri"/>
+                <a:ea typeface="Calibri"/>
+              </a:rPr>
+              <a:t>Manipal University</a:t>
+            </a:r>
+          </a:p>
+        </p:txBody>
+      </p:sp>
+      <p:sp>
+        <p:nvSpPr>
+          <p:cNvPr id="9" name="TextBox 8"/>
+          <p:cNvSpPr txBox="1"/>
+          <p:nvPr/>
+        </p:nvSpPr>
+        <p:spPr>
+          <a:xfrm>
+            <a:off x="411480" y="3840480"/>
+            <a:ext cx="4023360" cy="365760"/>
+          </a:xfrm>
+          <a:prstGeom prst="rect">
+            <a:avLst/>
+          </a:prstGeom>
+          <a:noFill/>
+        </p:spPr>
+        <p:txBody>
+          <a:bodyPr wrap="square" lIns="0" rIns="0" tIns="0" bIns="0" anchor="t"/>
+          <a:lstStyle/>
+          <a:p>
+            <a:pPr algn="l">
+              <a:spcBef>
+                <a:spcPts val="0"/>
+              </a:spcBef>
+              <a:spcAft>
+                <a:spcPts val="0"/>
+              </a:spcAft>
+            </a:pPr>
+            <a:r>
+              <a:rPr sz="1800" b="1" i="0">
+                <a:solidFill>
+                  <a:srgbClr val="FFFFFF"/>
+                </a:solidFill>
+                <a:latin typeface="Calibri"/>
+                <a:cs typeface="Calibri"/>
+                <a:ea typeface="Calibri"/>
+              </a:rPr>
+              <a:t>Team 65</a:t>
+            </a:r>
+          </a:p>
+        </p:txBody>
+      </p:sp>
+      <p:sp>
+        <p:nvSpPr>
+          <p:cNvPr id="10" name="TextBox 9"/>
+          <p:cNvSpPr txBox="1"/>
+          <p:nvPr/>
+        </p:nvSpPr>
+        <p:spPr>
+          <a:xfrm>
+            <a:off x="411480" y="4251960"/>
+            <a:ext cx="4023360" cy="365760"/>
+          </a:xfrm>
+          <a:prstGeom prst="rect">
+            <a:avLst/>
+          </a:prstGeom>
+          <a:noFill/>
+        </p:spPr>
+        <p:txBody>
+          <a:bodyPr wrap="square" lIns="0" rIns="0" tIns="0" bIns="0" anchor="t"/>
+          <a:lstStyle/>
+          <a:p>
+            <a:pPr algn="l">
+              <a:spcBef>
+                <a:spcPts val="0"/>
+              </a:spcBef>
+              <a:spcAft>
+                <a:spcPts val="0"/>
+              </a:spcAft>
+            </a:pPr>
+            <a:r>
+              <a:rPr sz="1600" b="0" i="0">
+                <a:solidFill>
+                  <a:srgbClr val="C5D0DC"/>
+                </a:solidFill>
+                <a:latin typeface="Calibri"/>
+                <a:cs typeface="Calibri"/>
+                <a:ea typeface="Calibri"/>
+              </a:rPr>
+              <a:t>Track 3, FinTech AI</a:t>
+            </a:r>
+          </a:p>
+        </p:txBody>
+      </p:sp>
+      <p:sp>
+        <p:nvSpPr>
+          <p:cNvPr id="11" name="TextBox 10"/>
+          <p:cNvSpPr txBox="1"/>
+          <p:nvPr/>
+        </p:nvSpPr>
+        <p:spPr>
+          <a:xfrm>
+            <a:off x="5120640" y="1965960"/>
+            <a:ext cx="6583680" cy="1051560"/>
+          </a:xfrm>
+          <a:prstGeom prst="rect">
+            <a:avLst/>
+          </a:prstGeom>
+          <a:noFill/>
+        </p:spPr>
+        <p:txBody>
+          <a:bodyPr wrap="square" lIns="0" rIns="0" tIns="0" bIns="0" anchor="t"/>
+          <a:lstStyle/>
+          <a:p>
+            <a:pPr algn="l">
+              <a:spcBef>
+                <a:spcPts val="0"/>
+              </a:spcBef>
+              <a:spcAft>
+                <a:spcPts val="0"/>
+              </a:spcAft>
+            </a:pPr>
+            <a:r>
+              <a:rPr sz="5400" b="1" i="0">
+                <a:solidFill>
+                  <a:srgbClr val="FFFFFF"/>
+                </a:solidFill>
+                <a:latin typeface="Calibri"/>
+                <a:cs typeface="Calibri"/>
+                <a:ea typeface="Calibri"/>
+              </a:rPr>
               <a:t>Thank you.</a:t>
             </a:r>
           </a:p>
@@ -10154,14 +10518,14 @@
       </p:sp>
       <p:sp>
         <p:nvSpPr>
-          <p:cNvPr id="5" name="TextBox 4"/>
-          <p:cNvSpPr txBox="1"/>
-          <p:nvPr/>
-        </p:nvSpPr>
-        <p:spPr>
-          <a:xfrm>
-            <a:off x="777240" y="1874519"/>
-            <a:ext cx="10058400" cy="384048"/>
+          <p:cNvPr id="12" name="TextBox 11"/>
+          <p:cNvSpPr txBox="1"/>
+          <p:nvPr/>
+        </p:nvSpPr>
+        <p:spPr>
+          <a:xfrm>
+            <a:off x="5120640" y="3291840"/>
+            <a:ext cx="6583680" cy="292608"/>
           </a:xfrm>
           <a:prstGeom prst="rect">
             <a:avLst/>
@@ -10181,29 +10545,29 @@
               </a:spcAft>
             </a:pPr>
             <a:r>
-              <a:rPr sz="2000" b="1" i="0">
-                <a:solidFill>
-                  <a:srgbClr val="C4922A"/>
-                </a:solidFill>
-                <a:latin typeface="Calibri"/>
-                <a:cs typeface="Calibri"/>
-                <a:ea typeface="Calibri"/>
-              </a:rPr>
-              <a:t>Team 65    ·    Manipal University    ·    Track 3, FinTech AI</a:t>
-            </a:r>
-          </a:p>
-        </p:txBody>
-      </p:sp>
-      <p:sp>
-        <p:nvSpPr>
-          <p:cNvPr id="6" name="TextBox 5"/>
-          <p:cNvSpPr txBox="1"/>
-          <p:nvPr/>
-        </p:nvSpPr>
-        <p:spPr>
-          <a:xfrm>
-            <a:off x="777240" y="2606040"/>
-            <a:ext cx="9144000" cy="502920"/>
+              <a:rPr sz="1600" b="0" i="0">
+                <a:solidFill>
+                  <a:srgbClr val="C5D0DC"/>
+                </a:solidFill>
+                <a:latin typeface="Calibri"/>
+                <a:cs typeface="Calibri"/>
+                <a:ea typeface="Calibri"/>
+              </a:rPr>
+              <a:t>Live site</a:t>
+            </a:r>
+          </a:p>
+        </p:txBody>
+      </p:sp>
+      <p:sp>
+        <p:nvSpPr>
+          <p:cNvPr id="13" name="TextBox 12"/>
+          <p:cNvSpPr txBox="1"/>
+          <p:nvPr/>
+        </p:nvSpPr>
+        <p:spPr>
+          <a:xfrm>
+            <a:off x="5120640" y="3611880"/>
+            <a:ext cx="6583680" cy="365760"/>
           </a:xfrm>
           <a:prstGeom prst="rect">
             <a:avLst/>
@@ -10222,101 +10586,6 @@
                 <a:spcPts val="0"/>
               </a:spcAft>
             </a:pPr>
-            <a:r>
-              <a:rPr sz="3000" b="1" i="0">
-                <a:solidFill>
-                  <a:srgbClr val="FFFFFF"/>
-                </a:solidFill>
-                <a:latin typeface="Calibri"/>
-                <a:cs typeface="Calibri"/>
-                <a:ea typeface="Calibri"/>
-              </a:rPr>
-              <a:t>Nancy Verma</a:t>
-            </a:r>
-          </a:p>
-        </p:txBody>
-      </p:sp>
-      <p:sp>
-        <p:nvSpPr>
-          <p:cNvPr id="7" name="TextBox 6"/>
-          <p:cNvSpPr txBox="1"/>
-          <p:nvPr/>
-        </p:nvSpPr>
-        <p:spPr>
-          <a:xfrm>
-            <a:off x="777240" y="3154680"/>
-            <a:ext cx="9144000" cy="502920"/>
-          </a:xfrm>
-          <a:prstGeom prst="rect">
-            <a:avLst/>
-          </a:prstGeom>
-          <a:noFill/>
-        </p:spPr>
-        <p:txBody>
-          <a:bodyPr wrap="square" lIns="0" rIns="0" tIns="0" bIns="0" anchor="t"/>
-          <a:lstStyle/>
-          <a:p>
-            <a:pPr algn="l">
-              <a:spcBef>
-                <a:spcPts val="0"/>
-              </a:spcBef>
-              <a:spcAft>
-                <a:spcPts val="0"/>
-              </a:spcAft>
-            </a:pPr>
-            <a:r>
-              <a:rPr sz="3000" b="1" i="0">
-                <a:solidFill>
-                  <a:srgbClr val="FFFFFF"/>
-                </a:solidFill>
-                <a:latin typeface="Calibri"/>
-                <a:cs typeface="Calibri"/>
-                <a:ea typeface="Calibri"/>
-              </a:rPr>
-              <a:t>Amisha Singh</a:t>
-            </a:r>
-          </a:p>
-        </p:txBody>
-      </p:sp>
-      <p:sp>
-        <p:nvSpPr>
-          <p:cNvPr id="8" name="TextBox 7"/>
-          <p:cNvSpPr txBox="1"/>
-          <p:nvPr/>
-        </p:nvSpPr>
-        <p:spPr>
-          <a:xfrm>
-            <a:off x="777240" y="4160520"/>
-            <a:ext cx="10058400" cy="365760"/>
-          </a:xfrm>
-          <a:prstGeom prst="rect">
-            <a:avLst/>
-          </a:prstGeom>
-          <a:noFill/>
-        </p:spPr>
-        <p:txBody>
-          <a:bodyPr wrap="square" lIns="0" rIns="0" tIns="0" bIns="0" anchor="t"/>
-          <a:lstStyle/>
-          <a:p>
-            <a:pPr algn="l">
-              <a:spcBef>
-                <a:spcPts val="0"/>
-              </a:spcBef>
-              <a:spcAft>
-                <a:spcPts val="0"/>
-              </a:spcAft>
-            </a:pPr>
-            <a:r>
-              <a:rPr sz="1800" b="0" i="0">
-                <a:solidFill>
-                  <a:srgbClr val="C5D0DC"/>
-                </a:solidFill>
-                <a:latin typeface="Calibri"/>
-                <a:cs typeface="Calibri"/>
-                <a:ea typeface="Calibri"/>
-              </a:rPr>
-              <a:t>Live site    </a:t>
-            </a:r>
             <a:r>
               <a:rPr sz="1800" b="1" i="0">
                 <a:solidFill>
@@ -10335,14 +10604,14 @@
       </p:sp>
       <p:sp>
         <p:nvSpPr>
-          <p:cNvPr id="9" name="TextBox 8"/>
-          <p:cNvSpPr txBox="1"/>
-          <p:nvPr/>
-        </p:nvSpPr>
-        <p:spPr>
-          <a:xfrm>
-            <a:off x="777240" y="4663440"/>
-            <a:ext cx="10058400" cy="365760"/>
+          <p:cNvPr id="14" name="TextBox 13"/>
+          <p:cNvSpPr txBox="1"/>
+          <p:nvPr/>
+        </p:nvSpPr>
+        <p:spPr>
+          <a:xfrm>
+            <a:off x="5120640" y="4160520"/>
+            <a:ext cx="6583680" cy="292608"/>
           </a:xfrm>
           <a:prstGeom prst="rect">
             <a:avLst/>
@@ -10362,7 +10631,7 @@
               </a:spcAft>
             </a:pPr>
             <a:r>
-              <a:rPr sz="1800" b="0" i="0">
+              <a:rPr sz="1600" b="0" i="0">
                 <a:solidFill>
                   <a:srgbClr val="C5D0DC"/>
                 </a:solidFill>
@@ -10370,10 +10639,41 @@
                 <a:cs typeface="Calibri"/>
                 <a:ea typeface="Calibri"/>
               </a:rPr>
-              <a:t>GitHub    </a:t>
-            </a:r>
-            <a:r>
-              <a:rPr sz="1800" b="1" i="0">
+              <a:t>GitHub</a:t>
+            </a:r>
+          </a:p>
+        </p:txBody>
+      </p:sp>
+      <p:sp>
+        <p:nvSpPr>
+          <p:cNvPr id="15" name="TextBox 14"/>
+          <p:cNvSpPr txBox="1"/>
+          <p:nvPr/>
+        </p:nvSpPr>
+        <p:spPr>
+          <a:xfrm>
+            <a:off x="5120640" y="4480560"/>
+            <a:ext cx="6583680" cy="365760"/>
+          </a:xfrm>
+          <a:prstGeom prst="rect">
+            <a:avLst/>
+          </a:prstGeom>
+          <a:noFill/>
+        </p:spPr>
+        <p:txBody>
+          <a:bodyPr wrap="square" lIns="0" rIns="0" tIns="0" bIns="0" anchor="t"/>
+          <a:lstStyle/>
+          <a:p>
+            <a:pPr algn="l">
+              <a:spcBef>
+                <a:spcPts val="0"/>
+              </a:spcBef>
+              <a:spcAft>
+                <a:spcPts val="0"/>
+              </a:spcAft>
+            </a:pPr>
+            <a:r>
+              <a:rPr sz="1600" b="1" i="0">
                 <a:solidFill>
                   <a:srgbClr val="C4922A"/>
                 </a:solidFill>
@@ -10390,7 +10690,7 @@
       </p:sp>
       <p:sp>
         <p:nvSpPr>
-          <p:cNvPr id="10" name="TextBox 9"/>
+          <p:cNvPr id="16" name="TextBox 15"/>
           <p:cNvSpPr txBox="1"/>
           <p:nvPr/>
         </p:nvSpPr>

</xml_diff>